<commit_message>
Add thesis extensions: anonymity penalty, combined revision analysis
- Add anonymity_penalty module for routing-based privacy analysis
- Add results_philly_combined_revision analysis with ZIP regression
- Add pull_philly_demographics.R for ACS block-group data
- Reorganize analysis figures into analysis/output/
- Update visualize_combined_detections.py paths to philly_combined_revision
- Add networkx and geopandas to requirements
- Update .gitignore: exclude cleanup/, screenshots, large data files
- Clean up old HTML outputs and reorganize figure files

Co-authored-by: Cursor <cursoragent@cursor.com>
</commit_message>
<xml_diff>
--- a/surveillance_pipeline.pptx
+++ b/surveillance_pipeline.pptx
@@ -950,8 +950,8 @@
         </p:nvSpPr>
         <p:spPr>
           <a:xfrm>
-            <a:off x="274320" y="960120"/>
-            <a:ext cx="2286000" cy="685800"/>
+            <a:off x="160020" y="960120"/>
+            <a:ext cx="2514600" cy="685800"/>
           </a:xfrm>
           <a:prstGeom prst="rect">
             <a:avLst/>
@@ -2012,9 +2012,7 @@
           <a:bodyPr wrap="square" rtlCol="0" anchor="ctr"/>
           <a:lstStyle/>
           <a:p>
-            <a:pPr marL="0" indent="0" algn="ctr">
-              <a:buNone/>
-            </a:pPr>
+            <a:pPr algn="ctr"/>
             <a:r>
               <a:rPr lang="en-US" sz="1000" b="1" dirty="0">
                 <a:solidFill>
@@ -2024,60 +2022,22 @@
                 <a:ea typeface="Calibri" pitchFamily="34" charset="-122"/>
                 <a:cs typeface="Calibri" pitchFamily="34" charset="-120"/>
               </a:rPr>
-              <a:t>Post Processing </a:t>
-            </a:r>
-          </a:p>
-          <a:p>
-            <a:pPr algn="ctr"/>
-            <a:r>
-              <a:rPr lang="en-US" sz="800" b="1" dirty="0">
-                <a:solidFill>
-                  <a:srgbClr val="111111"/>
-                </a:solidFill>
-                <a:latin typeface="Calibri" pitchFamily="34" charset="0"/>
-                <a:ea typeface="Calibri" pitchFamily="34" charset="-122"/>
-                <a:cs typeface="Calibri" pitchFamily="34" charset="-120"/>
-              </a:rPr>
-              <a:t>NMS + Score Aggregation</a:t>
-            </a:r>
-            <a:endParaRPr lang="en-US" sz="800" b="1" dirty="0"/>
-          </a:p>
-          <a:p>
-            <a:pPr algn="ctr"/>
-            <a:r>
-              <a:rPr lang="en-US" sz="800" dirty="0">
-                <a:solidFill>
-                  <a:srgbClr val="555555"/>
-                </a:solidFill>
-                <a:latin typeface="Calibri" pitchFamily="34" charset="0"/>
-                <a:ea typeface="Calibri" pitchFamily="34" charset="-122"/>
-                <a:cs typeface="Calibri" pitchFamily="34" charset="-120"/>
-              </a:rPr>
-              <a:t>Threshold </a:t>
-            </a:r>
-            <a:r>
-              <a:rPr lang="en-US" sz="800" dirty="0" err="1">
-                <a:solidFill>
-                  <a:srgbClr val="555555"/>
-                </a:solidFill>
-                <a:latin typeface="Calibri" pitchFamily="34" charset="0"/>
-                <a:ea typeface="Calibri" pitchFamily="34" charset="-122"/>
-                <a:cs typeface="Calibri" pitchFamily="34" charset="-120"/>
-              </a:rPr>
-              <a:t>τ</a:t>
-            </a:r>
-            <a:r>
-              <a:rPr lang="en-US" sz="800" dirty="0">
-                <a:solidFill>
-                  <a:srgbClr val="555555"/>
-                </a:solidFill>
-                <a:latin typeface="Calibri" pitchFamily="34" charset="0"/>
-                <a:ea typeface="Calibri" pitchFamily="34" charset="-122"/>
-                <a:cs typeface="Calibri" pitchFamily="34" charset="-120"/>
-              </a:rPr>
-              <a:t> = 0.4 </a:t>
+              <a:t>Human Validation</a:t>
             </a:r>
             <a:endParaRPr lang="en-US" sz="1000" dirty="0"/>
+          </a:p>
+          <a:p>
+            <a:pPr marL="0" indent="0" algn="ctr">
+              <a:buNone/>
+            </a:pPr>
+            <a:endParaRPr lang="en-US" sz="1000" b="1" dirty="0">
+              <a:solidFill>
+                <a:srgbClr val="111111"/>
+              </a:solidFill>
+              <a:latin typeface="Calibri" pitchFamily="34" charset="0"/>
+              <a:ea typeface="Calibri" pitchFamily="34" charset="-122"/>
+              <a:cs typeface="Calibri" pitchFamily="34" charset="-120"/>
+            </a:endParaRPr>
           </a:p>
         </p:txBody>
       </p:sp>
@@ -2155,7 +2115,7 @@
         </p:nvSpPr>
         <p:spPr>
           <a:xfrm>
-            <a:off x="3200400" y="4206240"/>
+            <a:off x="3218688" y="4206240"/>
             <a:ext cx="3108960" cy="713232"/>
           </a:xfrm>
           <a:prstGeom prst="rect">
@@ -2175,45 +2135,100 @@
           <a:bodyPr/>
           <a:lstStyle/>
           <a:p>
-            <a:endParaRPr lang="en-US"/>
-          </a:p>
-        </p:txBody>
-      </p:sp>
-      <p:sp>
-        <p:nvSpPr>
-          <p:cNvPr id="43" name="Text 41"/>
-          <p:cNvSpPr/>
-          <p:nvPr/>
-        </p:nvSpPr>
-        <p:spPr>
-          <a:xfrm>
-            <a:off x="3291840" y="4206240"/>
-            <a:ext cx="2926080" cy="713232"/>
-          </a:xfrm>
-          <a:prstGeom prst="rect">
-            <a:avLst/>
-          </a:prstGeom>
-          <a:noFill/>
-          <a:ln/>
-        </p:spPr>
-        <p:txBody>
-          <a:bodyPr wrap="square" rtlCol="0" anchor="ctr"/>
-          <a:lstStyle/>
-          <a:p>
-            <a:pPr marL="0" indent="0" algn="ctr">
-              <a:buNone/>
-            </a:pPr>
+            <a:pPr algn="ctr"/>
+            <a:endParaRPr lang="en-US" sz="1000" b="1" dirty="0">
+              <a:solidFill>
+                <a:srgbClr val="111111"/>
+              </a:solidFill>
+              <a:latin typeface="Calibri" pitchFamily="34" charset="0"/>
+              <a:cs typeface="Calibri" pitchFamily="34" charset="-120"/>
+            </a:endParaRPr>
+          </a:p>
+          <a:p>
+            <a:pPr algn="ctr"/>
             <a:r>
               <a:rPr lang="en-US" sz="1000" b="1" dirty="0">
                 <a:solidFill>
                   <a:srgbClr val="111111"/>
                 </a:solidFill>
                 <a:latin typeface="Calibri" pitchFamily="34" charset="0"/>
-                <a:ea typeface="Calibri" pitchFamily="34" charset="-122"/>
                 <a:cs typeface="Calibri" pitchFamily="34" charset="-120"/>
               </a:rPr>
-              <a:t>Human Validation</a:t>
+              <a:t>Post Processing </a:t>
             </a:r>
+          </a:p>
+          <a:p>
+            <a:pPr algn="ctr"/>
+            <a:r>
+              <a:rPr lang="en-US" sz="800" dirty="0">
+                <a:solidFill>
+                  <a:srgbClr val="555555"/>
+                </a:solidFill>
+                <a:latin typeface="Calibri" pitchFamily="34" charset="0"/>
+                <a:cs typeface="Calibri" pitchFamily="34" charset="-120"/>
+              </a:rPr>
+              <a:t>NMS + Score Aggregation</a:t>
+            </a:r>
+          </a:p>
+          <a:p>
+            <a:pPr algn="ctr"/>
+            <a:r>
+              <a:rPr lang="en-US" sz="800" dirty="0">
+                <a:solidFill>
+                  <a:srgbClr val="555555"/>
+                </a:solidFill>
+                <a:latin typeface="Calibri" pitchFamily="34" charset="0"/>
+                <a:cs typeface="Calibri" pitchFamily="34" charset="-120"/>
+              </a:rPr>
+              <a:t>Threshold </a:t>
+            </a:r>
+            <a:r>
+              <a:rPr lang="en-US" sz="800" dirty="0" err="1">
+                <a:solidFill>
+                  <a:srgbClr val="555555"/>
+                </a:solidFill>
+                <a:latin typeface="Calibri" pitchFamily="34" charset="0"/>
+                <a:cs typeface="Calibri" pitchFamily="34" charset="-120"/>
+              </a:rPr>
+              <a:t>τ</a:t>
+            </a:r>
+            <a:r>
+              <a:rPr lang="en-US" sz="800" dirty="0">
+                <a:solidFill>
+                  <a:srgbClr val="555555"/>
+                </a:solidFill>
+                <a:latin typeface="Calibri" pitchFamily="34" charset="0"/>
+                <a:cs typeface="Calibri" pitchFamily="34" charset="-120"/>
+              </a:rPr>
+              <a:t> = 0.4 </a:t>
+            </a:r>
+          </a:p>
+        </p:txBody>
+      </p:sp>
+      <p:sp>
+        <p:nvSpPr>
+          <p:cNvPr id="43" name="Text 41"/>
+          <p:cNvSpPr/>
+          <p:nvPr/>
+        </p:nvSpPr>
+        <p:spPr>
+          <a:xfrm>
+            <a:off x="3291840" y="4206240"/>
+            <a:ext cx="2926080" cy="713232"/>
+          </a:xfrm>
+          <a:prstGeom prst="rect">
+            <a:avLst/>
+          </a:prstGeom>
+          <a:noFill/>
+          <a:ln/>
+        </p:spPr>
+        <p:txBody>
+          <a:bodyPr wrap="square" rtlCol="0" anchor="ctr"/>
+          <a:lstStyle/>
+          <a:p>
+            <a:pPr marL="0" indent="0" algn="ctr">
+              <a:buNone/>
+            </a:pPr>
             <a:endParaRPr lang="en-US" sz="1000" dirty="0"/>
           </a:p>
         </p:txBody>

</xml_diff>